<commit_message>
End to end integration tested: Prompt squence used are: 1.Who are you? 2.Show me critical alerts 3.Are there any further details for web-server-prod-01? 4.What does the runbook say about high CPU utilization? 5.Can you predict about web-server-prod-01? 6.Check if there are any network issues with web-server-prod-01 7.What is the blast radius for web-server-prod-01?(What are impacted because of web-server-prod-01?) 8.Why is the greenlake-ops-portal slow?
</commit_message>
<xml_diff>
--- a/conversationalAgent/docs/HPE_AI_Autopilot_Demo.pptx
+++ b/conversationalAgent/docs/HPE_AI_Autopilot_Demo.pptx
@@ -4132,9 +4132,168 @@
           </a:p>
         </p:txBody>
       </p:sp>
+      <p:sp>
+        <p:nvSpPr>
+          <p:cNvPr id="13" name="TextBox 12"/>
+          <p:cNvSpPr txBox="1"/>
+          <p:nvPr/>
+        </p:nvSpPr>
+        <p:spPr>
+          <a:xfrm>
+            <a:off x="6400800" y="5623560"/>
+            <a:ext cx="5303520" cy="365760"/>
+          </a:xfrm>
+          <a:prstGeom prst="rect">
+            <a:avLst/>
+          </a:prstGeom>
+          <a:noFill/>
+        </p:spPr>
+        <p:txBody>
+          <a:bodyPr wrap="none">
+            <a:spAutoFit/>
+          </a:bodyPr>
+          <a:lstStyle/>
+          <a:p>
+            <a:pPr algn="ctr"/>
+            <a:r>
+              <a:rPr sz="1000">
+                <a:solidFill>
+                  <a:srgbClr val="999999"/>
+                </a:solidFill>
+              </a:rPr>
+              <a:t>MCP protocol exposes all 11 tools to VS Code Copilot and Claude Desktop</a:t>
+            </a:r>
+          </a:p>
+        </p:txBody>
+      </p:sp>
+      <p:sp>
+        <p:nvSpPr>
+          <p:cNvPr id="14" name="Rectangle 13"/>
+          <p:cNvSpPr/>
+          <p:nvPr/>
+        </p:nvSpPr>
+        <p:spPr>
+          <a:xfrm>
+            <a:off x="0" y="6400800"/>
+            <a:ext cx="12191695" cy="457200"/>
+          </a:xfrm>
+          <a:prstGeom prst="rect">
+            <a:avLst/>
+          </a:prstGeom>
+          <a:solidFill>
+            <a:srgbClr val="121220"/>
+          </a:solidFill>
+          <a:ln>
+            <a:noFill/>
+          </a:ln>
+        </p:spPr>
+        <p:style>
+          <a:lnRef idx="1">
+            <a:schemeClr val="accent1"/>
+          </a:lnRef>
+          <a:fillRef idx="3">
+            <a:schemeClr val="accent1"/>
+          </a:fillRef>
+          <a:effectRef idx="2">
+            <a:schemeClr val="accent1"/>
+          </a:effectRef>
+          <a:fontRef idx="minor">
+            <a:schemeClr val="lt1"/>
+          </a:fontRef>
+        </p:style>
+        <p:txBody>
+          <a:bodyPr wrap="none" rtlCol="0" anchor="ctr"/>
+          <a:lstStyle/>
+          <a:p>
+            <a:pPr algn="l"/>
+            <a:r>
+              <a:rPr sz="1000" b="1">
+                <a:solidFill>
+                  <a:srgbClr val="01A982"/>
+                </a:solidFill>
+              </a:rPr>
+              <a:t>  Hewlett Packard Enterprise</a:t>
+            </a:r>
+          </a:p>
+        </p:txBody>
+      </p:sp>
+      <p:sp>
+        <p:nvSpPr>
+          <p:cNvPr id="15" name="TextBox 14"/>
+          <p:cNvSpPr txBox="1"/>
+          <p:nvPr/>
+        </p:nvSpPr>
+        <p:spPr>
+          <a:xfrm>
+            <a:off x="5638647" y="6446520"/>
+            <a:ext cx="914400" cy="365760"/>
+          </a:xfrm>
+          <a:prstGeom prst="rect">
+            <a:avLst/>
+          </a:prstGeom>
+          <a:noFill/>
+        </p:spPr>
+        <p:txBody>
+          <a:bodyPr wrap="none">
+            <a:spAutoFit/>
+          </a:bodyPr>
+          <a:lstStyle/>
+          <a:p>
+            <a:pPr algn="ctr"/>
+            <a:r>
+              <a:rPr sz="900">
+                <a:solidFill>
+                  <a:srgbClr val="999999"/>
+                </a:solidFill>
+              </a:rPr>
+              <a:t>10 / 11</a:t>
+            </a:r>
+          </a:p>
+        </p:txBody>
+      </p:sp>
+      <p:sp>
+        <p:nvSpPr>
+          <p:cNvPr id="16" name="TextBox 15"/>
+          <p:cNvSpPr txBox="1"/>
+          <p:nvPr/>
+        </p:nvSpPr>
+        <p:spPr>
+          <a:xfrm>
+            <a:off x="9448495" y="6446520"/>
+            <a:ext cx="2560320" cy="365760"/>
+          </a:xfrm>
+          <a:prstGeom prst="rect">
+            <a:avLst/>
+          </a:prstGeom>
+          <a:noFill/>
+        </p:spPr>
+        <p:txBody>
+          <a:bodyPr wrap="none">
+            <a:spAutoFit/>
+          </a:bodyPr>
+          <a:lstStyle/>
+          <a:p>
+            <a:pPr algn="r"/>
+            <a:r>
+              <a:rPr sz="900" i="1">
+                <a:solidFill>
+                  <a:srgbClr val="999999"/>
+                </a:solidFill>
+              </a:rPr>
+              <a:t>Internal Use Only</a:t>
+            </a:r>
+          </a:p>
+        </p:txBody>
+      </p:sp>
       <p:pic>
         <p:nvPicPr>
-          <p:cNvPr id="12" name="Picture 11" descr="mcp-server.png"/>
+          <p:cNvPr id="17" name="Picture 16">
+            <a:extLst>
+              <a:ext uri="{FF2B5EF4-FFF2-40B4-BE49-F238E27FC236}">
+                <a16:creationId xmlns:a16="http://schemas.microsoft.com/office/drawing/2014/main" id="{50B1652B-8701-66E5-2961-0677A5579972}"/>
+              </a:ext>
+            </a:extLst>
+          </p:cNvPr>
           <p:cNvPicPr>
             <a:picLocks noChangeAspect="1"/>
           </p:cNvPicPr>
@@ -4148,167 +4307,14 @@
         </p:blipFill>
         <p:spPr>
           <a:xfrm>
-            <a:off x="6492240" y="2011680"/>
-            <a:ext cx="5120640" cy="3474720"/>
+            <a:off x="6982097" y="1916254"/>
+            <a:ext cx="4140926" cy="3684446"/>
           </a:xfrm>
           <a:prstGeom prst="rect">
             <a:avLst/>
           </a:prstGeom>
         </p:spPr>
       </p:pic>
-      <p:sp>
-        <p:nvSpPr>
-          <p:cNvPr id="13" name="TextBox 12"/>
-          <p:cNvSpPr txBox="1"/>
-          <p:nvPr/>
-        </p:nvSpPr>
-        <p:spPr>
-          <a:xfrm>
-            <a:off x="6400800" y="5623560"/>
-            <a:ext cx="5303520" cy="365760"/>
-          </a:xfrm>
-          <a:prstGeom prst="rect">
-            <a:avLst/>
-          </a:prstGeom>
-          <a:noFill/>
-        </p:spPr>
-        <p:txBody>
-          <a:bodyPr wrap="none">
-            <a:spAutoFit/>
-          </a:bodyPr>
-          <a:lstStyle/>
-          <a:p>
-            <a:pPr algn="ctr"/>
-            <a:r>
-              <a:rPr sz="1000">
-                <a:solidFill>
-                  <a:srgbClr val="999999"/>
-                </a:solidFill>
-              </a:rPr>
-              <a:t>MCP protocol exposes all 11 tools to VS Code Copilot and Claude Desktop</a:t>
-            </a:r>
-          </a:p>
-        </p:txBody>
-      </p:sp>
-      <p:sp>
-        <p:nvSpPr>
-          <p:cNvPr id="14" name="Rectangle 13"/>
-          <p:cNvSpPr/>
-          <p:nvPr/>
-        </p:nvSpPr>
-        <p:spPr>
-          <a:xfrm>
-            <a:off x="0" y="6400800"/>
-            <a:ext cx="12191695" cy="457200"/>
-          </a:xfrm>
-          <a:prstGeom prst="rect">
-            <a:avLst/>
-          </a:prstGeom>
-          <a:solidFill>
-            <a:srgbClr val="121220"/>
-          </a:solidFill>
-          <a:ln>
-            <a:noFill/>
-          </a:ln>
-        </p:spPr>
-        <p:style>
-          <a:lnRef idx="1">
-            <a:schemeClr val="accent1"/>
-          </a:lnRef>
-          <a:fillRef idx="3">
-            <a:schemeClr val="accent1"/>
-          </a:fillRef>
-          <a:effectRef idx="2">
-            <a:schemeClr val="accent1"/>
-          </a:effectRef>
-          <a:fontRef idx="minor">
-            <a:schemeClr val="lt1"/>
-          </a:fontRef>
-        </p:style>
-        <p:txBody>
-          <a:bodyPr wrap="none" rtlCol="0" anchor="ctr"/>
-          <a:lstStyle/>
-          <a:p>
-            <a:pPr algn="l"/>
-            <a:r>
-              <a:rPr sz="1000" b="1">
-                <a:solidFill>
-                  <a:srgbClr val="01A982"/>
-                </a:solidFill>
-              </a:rPr>
-              <a:t>  Hewlett Packard Enterprise</a:t>
-            </a:r>
-          </a:p>
-        </p:txBody>
-      </p:sp>
-      <p:sp>
-        <p:nvSpPr>
-          <p:cNvPr id="15" name="TextBox 14"/>
-          <p:cNvSpPr txBox="1"/>
-          <p:nvPr/>
-        </p:nvSpPr>
-        <p:spPr>
-          <a:xfrm>
-            <a:off x="5638647" y="6446520"/>
-            <a:ext cx="914400" cy="365760"/>
-          </a:xfrm>
-          <a:prstGeom prst="rect">
-            <a:avLst/>
-          </a:prstGeom>
-          <a:noFill/>
-        </p:spPr>
-        <p:txBody>
-          <a:bodyPr wrap="none">
-            <a:spAutoFit/>
-          </a:bodyPr>
-          <a:lstStyle/>
-          <a:p>
-            <a:pPr algn="ctr"/>
-            <a:r>
-              <a:rPr sz="900">
-                <a:solidFill>
-                  <a:srgbClr val="999999"/>
-                </a:solidFill>
-              </a:rPr>
-              <a:t>10 / 11</a:t>
-            </a:r>
-          </a:p>
-        </p:txBody>
-      </p:sp>
-      <p:sp>
-        <p:nvSpPr>
-          <p:cNvPr id="16" name="TextBox 15"/>
-          <p:cNvSpPr txBox="1"/>
-          <p:nvPr/>
-        </p:nvSpPr>
-        <p:spPr>
-          <a:xfrm>
-            <a:off x="9448495" y="6446520"/>
-            <a:ext cx="2560320" cy="365760"/>
-          </a:xfrm>
-          <a:prstGeom prst="rect">
-            <a:avLst/>
-          </a:prstGeom>
-          <a:noFill/>
-        </p:spPr>
-        <p:txBody>
-          <a:bodyPr wrap="none">
-            <a:spAutoFit/>
-          </a:bodyPr>
-          <a:lstStyle/>
-          <a:p>
-            <a:pPr algn="r"/>
-            <a:r>
-              <a:rPr sz="900" i="1">
-                <a:solidFill>
-                  <a:srgbClr val="999999"/>
-                </a:solidFill>
-              </a:rPr>
-              <a:t>Internal Use Only</a:t>
-            </a:r>
-          </a:p>
-        </p:txBody>
-      </p:sp>
     </p:spTree>
   </p:cSld>
   <p:clrMapOvr>

</xml_diff>

<commit_message>
Update name to HPE Autopilot
</commit_message>
<xml_diff>
--- a/conversationalAgent/docs/HPE_AI_Autopilot_Demo.pptx
+++ b/conversationalAgent/docs/HPE_AI_Autopilot_Demo.pptx
@@ -312,7 +312,7 @@
           <a:p>
             <a:fld id="{5BCAD085-E8A6-8845-BD4E-CB4CCA059FC4}" type="datetimeFigureOut">
               <a:rPr lang="en-US" smtClean="0"/>
-              <a:t>3/12/26</a:t>
+              <a:t>3/13/26</a:t>
             </a:fld>
             <a:endParaRPr lang="en-US"/>
           </a:p>
@@ -480,7 +480,7 @@
           <a:p>
             <a:fld id="{5BCAD085-E8A6-8845-BD4E-CB4CCA059FC4}" type="datetimeFigureOut">
               <a:rPr lang="en-US" smtClean="0"/>
-              <a:t>3/12/26</a:t>
+              <a:t>3/13/26</a:t>
             </a:fld>
             <a:endParaRPr lang="en-US"/>
           </a:p>
@@ -658,7 +658,7 @@
           <a:p>
             <a:fld id="{5BCAD085-E8A6-8845-BD4E-CB4CCA059FC4}" type="datetimeFigureOut">
               <a:rPr lang="en-US" smtClean="0"/>
-              <a:t>3/12/26</a:t>
+              <a:t>3/13/26</a:t>
             </a:fld>
             <a:endParaRPr lang="en-US"/>
           </a:p>
@@ -826,7 +826,7 @@
           <a:p>
             <a:fld id="{5BCAD085-E8A6-8845-BD4E-CB4CCA059FC4}" type="datetimeFigureOut">
               <a:rPr lang="en-US" smtClean="0"/>
-              <a:t>3/12/26</a:t>
+              <a:t>3/13/26</a:t>
             </a:fld>
             <a:endParaRPr lang="en-US"/>
           </a:p>
@@ -1071,7 +1071,7 @@
           <a:p>
             <a:fld id="{5BCAD085-E8A6-8845-BD4E-CB4CCA059FC4}" type="datetimeFigureOut">
               <a:rPr lang="en-US" smtClean="0"/>
-              <a:t>3/12/26</a:t>
+              <a:t>3/13/26</a:t>
             </a:fld>
             <a:endParaRPr lang="en-US"/>
           </a:p>
@@ -1356,7 +1356,7 @@
           <a:p>
             <a:fld id="{5BCAD085-E8A6-8845-BD4E-CB4CCA059FC4}" type="datetimeFigureOut">
               <a:rPr lang="en-US" smtClean="0"/>
-              <a:t>3/12/26</a:t>
+              <a:t>3/13/26</a:t>
             </a:fld>
             <a:endParaRPr lang="en-US"/>
           </a:p>
@@ -1775,7 +1775,7 @@
           <a:p>
             <a:fld id="{5BCAD085-E8A6-8845-BD4E-CB4CCA059FC4}" type="datetimeFigureOut">
               <a:rPr lang="en-US" smtClean="0"/>
-              <a:t>3/12/26</a:t>
+              <a:t>3/13/26</a:t>
             </a:fld>
             <a:endParaRPr lang="en-US"/>
           </a:p>
@@ -1892,7 +1892,7 @@
           <a:p>
             <a:fld id="{5BCAD085-E8A6-8845-BD4E-CB4CCA059FC4}" type="datetimeFigureOut">
               <a:rPr lang="en-US" smtClean="0"/>
-              <a:t>3/12/26</a:t>
+              <a:t>3/13/26</a:t>
             </a:fld>
             <a:endParaRPr lang="en-US"/>
           </a:p>
@@ -1987,7 +1987,7 @@
           <a:p>
             <a:fld id="{5BCAD085-E8A6-8845-BD4E-CB4CCA059FC4}" type="datetimeFigureOut">
               <a:rPr lang="en-US" smtClean="0"/>
-              <a:t>3/12/26</a:t>
+              <a:t>3/13/26</a:t>
             </a:fld>
             <a:endParaRPr lang="en-US"/>
           </a:p>
@@ -2262,7 +2262,7 @@
           <a:p>
             <a:fld id="{5BCAD085-E8A6-8845-BD4E-CB4CCA059FC4}" type="datetimeFigureOut">
               <a:rPr lang="en-US" smtClean="0"/>
-              <a:t>3/12/26</a:t>
+              <a:t>3/13/26</a:t>
             </a:fld>
             <a:endParaRPr lang="en-US"/>
           </a:p>
@@ -2514,7 +2514,7 @@
           <a:p>
             <a:fld id="{5BCAD085-E8A6-8845-BD4E-CB4CCA059FC4}" type="datetimeFigureOut">
               <a:rPr lang="en-US" smtClean="0"/>
-              <a:t>3/12/26</a:t>
+              <a:t>3/13/26</a:t>
             </a:fld>
             <a:endParaRPr lang="en-US"/>
           </a:p>
@@ -2725,7 +2725,7 @@
           <a:p>
             <a:fld id="{5BCAD085-E8A6-8845-BD4E-CB4CCA059FC4}" type="datetimeFigureOut">
               <a:rPr lang="en-US" smtClean="0"/>
-              <a:t>3/12/26</a:t>
+              <a:t>3/13/26</a:t>
             </a:fld>
             <a:endParaRPr lang="en-US"/>
           </a:p>
@@ -3995,30 +3995,6 @@
           </a:p>
         </p:txBody>
       </p:sp>
-      <p:pic>
-        <p:nvPicPr>
-          <p:cNvPr id="8" name="Picture 7" descr="web-ui.png"/>
-          <p:cNvPicPr>
-            <a:picLocks noChangeAspect="1"/>
-          </p:cNvPicPr>
-          <p:nvPr/>
-        </p:nvPicPr>
-        <p:blipFill>
-          <a:blip r:embed="rId2"/>
-          <a:stretch>
-            <a:fillRect/>
-          </a:stretch>
-        </p:blipFill>
-        <p:spPr>
-          <a:xfrm>
-            <a:off x="822960" y="2011680"/>
-            <a:ext cx="5120640" cy="3474720"/>
-          </a:xfrm>
-          <a:prstGeom prst="rect">
-            <a:avLst/>
-          </a:prstGeom>
-        </p:spPr>
-      </p:pic>
       <p:sp>
         <p:nvSpPr>
           <p:cNvPr id="9" name="TextBox 8"/>
@@ -4300,6 +4276,36 @@
           <p:nvPr/>
         </p:nvPicPr>
         <p:blipFill>
+          <a:blip r:embed="rId2"/>
+          <a:stretch>
+            <a:fillRect/>
+          </a:stretch>
+        </p:blipFill>
+        <p:spPr>
+          <a:xfrm>
+            <a:off x="6982097" y="1916254"/>
+            <a:ext cx="4140926" cy="3684446"/>
+          </a:xfrm>
+          <a:prstGeom prst="rect">
+            <a:avLst/>
+          </a:prstGeom>
+        </p:spPr>
+      </p:pic>
+      <p:pic>
+        <p:nvPicPr>
+          <p:cNvPr id="12" name="Picture 11">
+            <a:extLst>
+              <a:ext uri="{FF2B5EF4-FFF2-40B4-BE49-F238E27FC236}">
+                <a16:creationId xmlns:a16="http://schemas.microsoft.com/office/drawing/2014/main" id="{B7B433FC-D08F-B1F6-52BA-A8C66FF124B5}"/>
+              </a:ext>
+            </a:extLst>
+          </p:cNvPr>
+          <p:cNvPicPr>
+            <a:picLocks noChangeAspect="1"/>
+          </p:cNvPicPr>
+          <p:nvPr/>
+        </p:nvPicPr>
+        <p:blipFill>
           <a:blip r:embed="rId3"/>
           <a:stretch>
             <a:fillRect/>
@@ -4307,8 +4313,8 @@
         </p:blipFill>
         <p:spPr>
           <a:xfrm>
-            <a:off x="6982097" y="1916254"/>
-            <a:ext cx="4140926" cy="3684446"/>
+            <a:off x="646425" y="2209715"/>
+            <a:ext cx="5510537" cy="3172182"/>
           </a:xfrm>
           <a:prstGeom prst="rect">
             <a:avLst/>

</xml_diff>